<commit_message>
Docs + deck v4: system diagram, BLE walkthrough, linear data-flow slide
- docs/system-diagram.png: one-page Eraser system diagram, linked as
  the start-here figure in ARCHITECTURE.md
- docs/BLE_LINK_WALKTHROUGH.md: scan/connect/bond/subscribe/drain
  explained state by state with the shipped ble_link.cpp code and the
  why behind each choice, plus the end-to-end packet journey as a
  numbered 7-step narrative
- Deck: slide 2 is now Shared Foundations, slide 3 the system diagram;
  data-flow slide rebuilt as one numbered left-to-right pipeline
  (across vehicles then inside the display); BLE slide states match
  the real code (NVS direct connect, Just Works NO_PIN); speaker notes
  carry the code walkthrough; 2 Hz render corrected; generator script
  committed alongside the pptx

Co-Authored-By: Claude Fable 5 <noreply@anthropic.com>
</commit_message>
<xml_diff>
--- a/docs/presentations/Group9_Presentation2_Weeks1-2.pptx
+++ b/docs/presentations/Group9_Presentation2_Weeks1-2.pptx
@@ -686,7 +686,7 @@
           <a:p>
             <a:r>
               <a:rPr lang="en-US" dirty="0"/>
-              <a:t/>
+              <a:t>Single-page system view (drawn in Eraser, kept in docs/system-diagram.png). Walk left to right: hardware per vehicle, then the firmware split with TrackerState as the contract, then the telecom-layer view at the bottom. Vehicle B is identical.</a:t>
             </a:r>
             <a:endParaRPr lang="en-US" dirty="0"/>
           </a:p>
@@ -1038,7 +1038,7 @@
           <a:p>
             <a:r>
               <a:rPr lang="en-US" dirty="0"/>
-              <a:t/>
+              <a:t>One packet's journey, numbered: (1) partner GNSS computes a fix, 1 Hz NMEA over UART. (2) Meshtastic B builds a Position packet — lat/lon, speed, track, GPS time — and broadcasts over LoRa every 30-60 s (smart: 30 s / 50 m while moving). (3) Meshtastic A decrypts, files it in its node DB, queues it on FromRadio, rings the FromNum doorbell. (4) protocol/ drains the queue over BLE and nanopb-decodes each frame into node_table. (5) node_table publishes TrackerState once a second — one writer. (6) nav engine reads it — one reader — haversine distance, bearing minus own COG. (7) ui_render redraws at 2 Hz. Full narrative with code: docs/BLE_LINK_WALKTHROUGH.md.</a:t>
             </a:r>
             <a:endParaRPr lang="en-US" dirty="0"/>
           </a:p>
@@ -1126,7 +1126,7 @@
           <a:p>
             <a:r>
               <a:rPr lang="en-US" dirty="0"/>
-              <a:t/>
+              <a:t>How each state works in the shipped code (docs/BLE_LINK_WALKTHROUGH.md has the full excerpts): SCANNING - direct connect to the radio address remembered in NVS first (a Meshtastic radio only general-advertises from boot until its first disconnect, so a scan alone can never reconnect); 1.5 s scan fallback handles first pairing and radio replacement, exponential backoff 1-8 s. CONNECTING - 3 attempts, 10 s each; +9 dBm TX because default power was marginal; MTU 517 so a protobuf frame fits one read. BONDING - Just Works encrypted pairing on every connect; no stored bond ON PURPOSE: a bonded Meshtastic peripheral stops advertising entirely (bench-proven trap). SUBSCRIBED - subscribe FromNum (the doorbell), then write want_config_id with a random nonce so the radio replays its whole node DB; nonce back = snapshot complete. DRAINING - read FromRadio until a zero-length read; one notify can mean many queued frames. Every failure funnels through one teardown back to SCANNING - no state can wedge. Road-proven: mid-carry disconnect on Sep 1 self-recovered with no user action.</a:t>
             </a:r>
             <a:endParaRPr lang="en-US" dirty="0"/>
           </a:p>
@@ -2486,1412 +2486,6 @@
                 <a:ea typeface="Cambria" pitchFamily="34" charset="-122"/>
                 <a:cs typeface="Cambria" pitchFamily="34" charset="-120"/>
               </a:rPr>
-              <a:t>System Architecture — Overview &amp; Rationale</a:t>
-            </a:r>
-            <a:endParaRPr lang="en-US" sz="3000" dirty="0"/>
-          </a:p>
-        </p:txBody>
-      </p:sp>
-      <p:sp>
-        <p:nvSpPr>
-          <p:cNvPr id="3" name="Shape 1"/>
-          <p:cNvSpPr/>
-          <p:nvPr/>
-        </p:nvSpPr>
-        <p:spPr>
-          <a:xfrm>
-            <a:off x="502920" y="1234440"/>
-            <a:ext cx="3291840" cy="3200400"/>
-          </a:xfrm>
-          <a:prstGeom prst="roundRect">
-            <a:avLst>
-              <a:gd name="adj" fmla="val 3429"/>
-            </a:avLst>
-          </a:prstGeom>
-          <a:solidFill>
-            <a:srgbClr val="F2F6FC"/>
-          </a:solidFill>
-          <a:ln w="15875">
-            <a:solidFill>
-              <a:srgbClr val="1E2761"/>
-            </a:solidFill>
-            <a:prstDash val="solid"/>
-          </a:ln>
-        </p:spPr>
-      </p:sp>
-      <p:sp>
-        <p:nvSpPr>
-          <p:cNvPr id="4" name="Text 2"/>
-          <p:cNvSpPr txBox="1"/>
-          <p:nvPr/>
-        </p:nvSpPr>
-        <p:spPr>
-          <a:xfrm>
-            <a:off x="502920" y="1325880"/>
-            <a:ext cx="3291840" cy="320040"/>
-          </a:xfrm>
-          <a:prstGeom prst="rect">
-            <a:avLst/>
-          </a:prstGeom>
-          <a:noFill/>
-          <a:ln/>
-        </p:spPr>
-        <p:txBody>
-          <a:bodyPr wrap="square" lIns="0" tIns="0" rIns="0" bIns="0" rtlCol="0" anchor="ctr"/>
-          <a:lstStyle/>
-          <a:p>
-            <a:pPr algn="ctr" indent="0" marL="0">
-              <a:buNone/>
-            </a:pPr>
-            <a:r>
-              <a:rPr lang="en-US" sz="1400" b="1" dirty="0">
-                <a:solidFill>
-                  <a:srgbClr val="1E2761"/>
-                </a:solidFill>
-                <a:latin typeface="Calibri" pitchFamily="34" charset="0"/>
-                <a:ea typeface="Calibri" pitchFamily="34" charset="-122"/>
-                <a:cs typeface="Calibri" pitchFamily="34" charset="-120"/>
-              </a:rPr>
-              <a:t>VEHICLE A</a:t>
-            </a:r>
-            <a:endParaRPr lang="en-US" sz="1400" dirty="0"/>
-          </a:p>
-        </p:txBody>
-      </p:sp>
-      <p:sp>
-        <p:nvSpPr>
-          <p:cNvPr id="5" name="Shape 3"/>
-          <p:cNvSpPr/>
-          <p:nvPr/>
-        </p:nvSpPr>
-        <p:spPr>
-          <a:xfrm>
-            <a:off x="731520" y="1737360"/>
-            <a:ext cx="2834640" cy="960120"/>
-          </a:xfrm>
-          <a:prstGeom prst="roundRect">
-            <a:avLst>
-              <a:gd name="adj" fmla="val 6667"/>
-            </a:avLst>
-          </a:prstGeom>
-          <a:solidFill>
-            <a:srgbClr val="FFFFFF"/>
-          </a:solidFill>
-          <a:ln w="19050">
-            <a:solidFill>
-              <a:srgbClr val="1E2761"/>
-            </a:solidFill>
-            <a:prstDash val="solid"/>
-          </a:ln>
-        </p:spPr>
-      </p:sp>
-      <p:sp>
-        <p:nvSpPr>
-          <p:cNvPr id="6" name="Text 4"/>
-          <p:cNvSpPr txBox="1"/>
-          <p:nvPr/>
-        </p:nvSpPr>
-        <p:spPr>
-          <a:xfrm>
-            <a:off x="822960" y="1828800"/>
-            <a:ext cx="2697480" cy="777240"/>
-          </a:xfrm>
-          <a:prstGeom prst="rect">
-            <a:avLst/>
-          </a:prstGeom>
-          <a:noFill/>
-          <a:ln/>
-        </p:spPr>
-        <p:txBody>
-          <a:bodyPr wrap="square" lIns="0" tIns="0" rIns="0" bIns="0" rtlCol="0" anchor="ctr"/>
-          <a:lstStyle/>
-          <a:p>
-            <a:pPr indent="0" marL="0">
-              <a:buNone/>
-            </a:pPr>
-            <a:r>
-              <a:rPr lang="en-US" sz="1250" b="1" dirty="0">
-                <a:solidFill>
-                  <a:srgbClr val="1E2761"/>
-                </a:solidFill>
-                <a:latin typeface="Calibri" pitchFamily="34" charset="0"/>
-                <a:ea typeface="Calibri" pitchFamily="34" charset="-122"/>
-                <a:cs typeface="Calibri" pitchFamily="34" charset="-120"/>
-              </a:rPr>
-              <a:t>Heltec V4 — radio node</a:t>
-            </a:r>
-            <a:endParaRPr lang="en-US" sz="1250" dirty="0"/>
-          </a:p>
-          <a:p>
-            <a:pPr indent="0" marL="0">
-              <a:buNone/>
-            </a:pPr>
-            <a:r>
-              <a:rPr lang="en-US" sz="1050" dirty="0">
-                <a:solidFill>
-                  <a:srgbClr val="5B6B8A"/>
-                </a:solidFill>
-                <a:latin typeface="Calibri" pitchFamily="34" charset="0"/>
-                <a:ea typeface="Calibri" pitchFamily="34" charset="-122"/>
-                <a:cs typeface="Calibri" pitchFamily="34" charset="-120"/>
-              </a:rPr>
-              <a:t>ESP32-S3 · SX1262 LoRa · GNSS</a:t>
-            </a:r>
-            <a:endParaRPr lang="en-US" sz="1250" dirty="0"/>
-          </a:p>
-        </p:txBody>
-      </p:sp>
-      <p:sp>
-        <p:nvSpPr>
-          <p:cNvPr id="7" name="Text 5"/>
-          <p:cNvSpPr txBox="1"/>
-          <p:nvPr/>
-        </p:nvSpPr>
-        <p:spPr>
-          <a:xfrm>
-            <a:off x="822960" y="2395728"/>
-            <a:ext cx="2697480" cy="274320"/>
-          </a:xfrm>
-          <a:prstGeom prst="rect">
-            <a:avLst/>
-          </a:prstGeom>
-          <a:noFill/>
-          <a:ln/>
-        </p:spPr>
-        <p:txBody>
-          <a:bodyPr wrap="square" lIns="0" tIns="0" rIns="0" bIns="0" rtlCol="0" anchor="ctr"/>
-          <a:lstStyle/>
-          <a:p>
-            <a:pPr indent="0" marL="0">
-              <a:buNone/>
-            </a:pPr>
-            <a:r>
-              <a:rPr lang="en-US" sz="1000" i="1" dirty="0">
-                <a:solidFill>
-                  <a:srgbClr val="5B6B8A"/>
-                </a:solidFill>
-                <a:latin typeface="Calibri" pitchFamily="34" charset="0"/>
-                <a:ea typeface="Calibri" pitchFamily="34" charset="-122"/>
-                <a:cs typeface="Calibri" pitchFamily="34" charset="-120"/>
-              </a:rPr>
-              <a:t>stock Meshtastic firmware</a:t>
-            </a:r>
-            <a:endParaRPr lang="en-US" sz="1000" dirty="0"/>
-          </a:p>
-        </p:txBody>
-      </p:sp>
-      <p:sp>
-        <p:nvSpPr>
-          <p:cNvPr id="8" name="Shape 6"/>
-          <p:cNvSpPr/>
-          <p:nvPr/>
-        </p:nvSpPr>
-        <p:spPr>
-          <a:xfrm>
-            <a:off x="2148840" y="2697480"/>
-            <a:ext cx="0" cy="548640"/>
-          </a:xfrm>
-          <a:prstGeom prst="line">
-            <a:avLst/>
-          </a:prstGeom>
-          <a:noFill/>
-          <a:ln w="25400">
-            <a:solidFill>
-              <a:srgbClr val="E58E1A"/>
-            </a:solidFill>
-            <a:prstDash val="solid"/>
-            <a:tailEnd type="triangle"/>
-          </a:ln>
-        </p:spPr>
-      </p:sp>
-      <p:sp>
-        <p:nvSpPr>
-          <p:cNvPr id="9" name="Text 7"/>
-          <p:cNvSpPr txBox="1"/>
-          <p:nvPr/>
-        </p:nvSpPr>
-        <p:spPr>
-          <a:xfrm>
-            <a:off x="2221992" y="2843784"/>
-            <a:ext cx="1463040" cy="256032"/>
-          </a:xfrm>
-          <a:prstGeom prst="rect">
-            <a:avLst/>
-          </a:prstGeom>
-          <a:noFill/>
-          <a:ln/>
-        </p:spPr>
-        <p:txBody>
-          <a:bodyPr wrap="square" lIns="0" tIns="0" rIns="0" bIns="0" rtlCol="0" anchor="ctr"/>
-          <a:lstStyle/>
-          <a:p>
-            <a:pPr indent="0" marL="0">
-              <a:buNone/>
-            </a:pPr>
-            <a:r>
-              <a:rPr lang="en-US" sz="950" b="1" dirty="0">
-                <a:solidFill>
-                  <a:srgbClr val="E58E1A"/>
-                </a:solidFill>
-                <a:latin typeface="Calibri" pitchFamily="34" charset="0"/>
-                <a:ea typeface="Calibri" pitchFamily="34" charset="-122"/>
-                <a:cs typeface="Calibri" pitchFamily="34" charset="-120"/>
-              </a:rPr>
-              <a:t>BLE</a:t>
-            </a:r>
-            <a:endParaRPr lang="en-US" sz="950" dirty="0"/>
-          </a:p>
-        </p:txBody>
-      </p:sp>
-      <p:sp>
-        <p:nvSpPr>
-          <p:cNvPr id="10" name="Shape 8"/>
-          <p:cNvSpPr/>
-          <p:nvPr/>
-        </p:nvSpPr>
-        <p:spPr>
-          <a:xfrm>
-            <a:off x="731520" y="3246120"/>
-            <a:ext cx="2834640" cy="960120"/>
-          </a:xfrm>
-          <a:prstGeom prst="roundRect">
-            <a:avLst>
-              <a:gd name="adj" fmla="val 6667"/>
-            </a:avLst>
-          </a:prstGeom>
-          <a:solidFill>
-            <a:srgbClr val="FFFFFF"/>
-          </a:solidFill>
-          <a:ln w="19050">
-            <a:solidFill>
-              <a:srgbClr val="6D4BDB"/>
-            </a:solidFill>
-            <a:prstDash val="solid"/>
-          </a:ln>
-        </p:spPr>
-      </p:sp>
-      <p:sp>
-        <p:nvSpPr>
-          <p:cNvPr id="11" name="Text 9"/>
-          <p:cNvSpPr txBox="1"/>
-          <p:nvPr/>
-        </p:nvSpPr>
-        <p:spPr>
-          <a:xfrm>
-            <a:off x="822960" y="3346704"/>
-            <a:ext cx="2697480" cy="731520"/>
-          </a:xfrm>
-          <a:prstGeom prst="rect">
-            <a:avLst/>
-          </a:prstGeom>
-          <a:noFill/>
-          <a:ln/>
-        </p:spPr>
-        <p:txBody>
-          <a:bodyPr wrap="square" lIns="0" tIns="0" rIns="0" bIns="0" rtlCol="0" anchor="ctr"/>
-          <a:lstStyle/>
-          <a:p>
-            <a:pPr indent="0" marL="0">
-              <a:buNone/>
-            </a:pPr>
-            <a:r>
-              <a:rPr lang="en-US" sz="1250" b="1" dirty="0">
-                <a:solidFill>
-                  <a:srgbClr val="1E2761"/>
-                </a:solidFill>
-                <a:latin typeface="Calibri" pitchFamily="34" charset="0"/>
-                <a:ea typeface="Calibri" pitchFamily="34" charset="-122"/>
-                <a:cs typeface="Calibri" pitchFamily="34" charset="-120"/>
-              </a:rPr>
-              <a:t>Waveshare 4.2″ RLCD — display</a:t>
-            </a:r>
-            <a:endParaRPr lang="en-US" sz="1250" dirty="0"/>
-          </a:p>
-          <a:p>
-            <a:pPr indent="0" marL="0">
-              <a:buNone/>
-            </a:pPr>
-            <a:r>
-              <a:rPr lang="en-US" sz="1050" dirty="0">
-                <a:solidFill>
-                  <a:srgbClr val="5B6B8A"/>
-                </a:solidFill>
-                <a:latin typeface="Calibri" pitchFamily="34" charset="0"/>
-                <a:ea typeface="Calibri" pitchFamily="34" charset="-122"/>
-                <a:cs typeface="Calibri" pitchFamily="34" charset="-120"/>
-              </a:rPr>
-              <a:t>our only custom firmware</a:t>
-            </a:r>
-            <a:endParaRPr lang="en-US" sz="1250" dirty="0"/>
-          </a:p>
-        </p:txBody>
-      </p:sp>
-      <p:sp>
-        <p:nvSpPr>
-          <p:cNvPr id="12" name="Shape 10"/>
-          <p:cNvSpPr/>
-          <p:nvPr/>
-        </p:nvSpPr>
-        <p:spPr>
-          <a:xfrm>
-            <a:off x="4572000" y="1234440"/>
-            <a:ext cx="3291840" cy="3200400"/>
-          </a:xfrm>
-          <a:prstGeom prst="roundRect">
-            <a:avLst>
-              <a:gd name="adj" fmla="val 3429"/>
-            </a:avLst>
-          </a:prstGeom>
-          <a:solidFill>
-            <a:srgbClr val="F2F6FC"/>
-          </a:solidFill>
-          <a:ln w="15875">
-            <a:solidFill>
-              <a:srgbClr val="1E2761"/>
-            </a:solidFill>
-            <a:prstDash val="solid"/>
-          </a:ln>
-        </p:spPr>
-      </p:sp>
-      <p:sp>
-        <p:nvSpPr>
-          <p:cNvPr id="13" name="Text 11"/>
-          <p:cNvSpPr txBox="1"/>
-          <p:nvPr/>
-        </p:nvSpPr>
-        <p:spPr>
-          <a:xfrm>
-            <a:off x="4572000" y="1325880"/>
-            <a:ext cx="3291840" cy="320040"/>
-          </a:xfrm>
-          <a:prstGeom prst="rect">
-            <a:avLst/>
-          </a:prstGeom>
-          <a:noFill/>
-          <a:ln/>
-        </p:spPr>
-        <p:txBody>
-          <a:bodyPr wrap="square" lIns="0" tIns="0" rIns="0" bIns="0" rtlCol="0" anchor="ctr"/>
-          <a:lstStyle/>
-          <a:p>
-            <a:pPr algn="ctr" indent="0" marL="0">
-              <a:buNone/>
-            </a:pPr>
-            <a:r>
-              <a:rPr lang="en-US" sz="1400" b="1" dirty="0">
-                <a:solidFill>
-                  <a:srgbClr val="1E2761"/>
-                </a:solidFill>
-                <a:latin typeface="Calibri" pitchFamily="34" charset="0"/>
-                <a:ea typeface="Calibri" pitchFamily="34" charset="-122"/>
-                <a:cs typeface="Calibri" pitchFamily="34" charset="-120"/>
-              </a:rPr>
-              <a:t>VEHICLE B</a:t>
-            </a:r>
-            <a:endParaRPr lang="en-US" sz="1400" dirty="0"/>
-          </a:p>
-        </p:txBody>
-      </p:sp>
-      <p:sp>
-        <p:nvSpPr>
-          <p:cNvPr id="14" name="Shape 12"/>
-          <p:cNvSpPr/>
-          <p:nvPr/>
-        </p:nvSpPr>
-        <p:spPr>
-          <a:xfrm>
-            <a:off x="4800600" y="1737360"/>
-            <a:ext cx="2834640" cy="960120"/>
-          </a:xfrm>
-          <a:prstGeom prst="roundRect">
-            <a:avLst>
-              <a:gd name="adj" fmla="val 6667"/>
-            </a:avLst>
-          </a:prstGeom>
-          <a:solidFill>
-            <a:srgbClr val="FFFFFF"/>
-          </a:solidFill>
-          <a:ln w="19050">
-            <a:solidFill>
-              <a:srgbClr val="1E2761"/>
-            </a:solidFill>
-            <a:prstDash val="solid"/>
-          </a:ln>
-        </p:spPr>
-      </p:sp>
-      <p:sp>
-        <p:nvSpPr>
-          <p:cNvPr id="15" name="Text 13"/>
-          <p:cNvSpPr txBox="1"/>
-          <p:nvPr/>
-        </p:nvSpPr>
-        <p:spPr>
-          <a:xfrm>
-            <a:off x="4892040" y="1828800"/>
-            <a:ext cx="2697480" cy="777240"/>
-          </a:xfrm>
-          <a:prstGeom prst="rect">
-            <a:avLst/>
-          </a:prstGeom>
-          <a:noFill/>
-          <a:ln/>
-        </p:spPr>
-        <p:txBody>
-          <a:bodyPr wrap="square" lIns="0" tIns="0" rIns="0" bIns="0" rtlCol="0" anchor="ctr"/>
-          <a:lstStyle/>
-          <a:p>
-            <a:pPr indent="0" marL="0">
-              <a:buNone/>
-            </a:pPr>
-            <a:r>
-              <a:rPr lang="en-US" sz="1250" b="1" dirty="0">
-                <a:solidFill>
-                  <a:srgbClr val="1E2761"/>
-                </a:solidFill>
-                <a:latin typeface="Calibri" pitchFamily="34" charset="0"/>
-                <a:ea typeface="Calibri" pitchFamily="34" charset="-122"/>
-                <a:cs typeface="Calibri" pitchFamily="34" charset="-120"/>
-              </a:rPr>
-              <a:t>Heltec V4 — radio node</a:t>
-            </a:r>
-            <a:endParaRPr lang="en-US" sz="1250" dirty="0"/>
-          </a:p>
-          <a:p>
-            <a:pPr indent="0" marL="0">
-              <a:buNone/>
-            </a:pPr>
-            <a:r>
-              <a:rPr lang="en-US" sz="1050" dirty="0">
-                <a:solidFill>
-                  <a:srgbClr val="5B6B8A"/>
-                </a:solidFill>
-                <a:latin typeface="Calibri" pitchFamily="34" charset="0"/>
-                <a:ea typeface="Calibri" pitchFamily="34" charset="-122"/>
-                <a:cs typeface="Calibri" pitchFamily="34" charset="-120"/>
-              </a:rPr>
-              <a:t>ESP32-S3 · SX1262 LoRa · GNSS</a:t>
-            </a:r>
-            <a:endParaRPr lang="en-US" sz="1250" dirty="0"/>
-          </a:p>
-        </p:txBody>
-      </p:sp>
-      <p:sp>
-        <p:nvSpPr>
-          <p:cNvPr id="16" name="Text 14"/>
-          <p:cNvSpPr txBox="1"/>
-          <p:nvPr/>
-        </p:nvSpPr>
-        <p:spPr>
-          <a:xfrm>
-            <a:off x="4892040" y="2395728"/>
-            <a:ext cx="2697480" cy="274320"/>
-          </a:xfrm>
-          <a:prstGeom prst="rect">
-            <a:avLst/>
-          </a:prstGeom>
-          <a:noFill/>
-          <a:ln/>
-        </p:spPr>
-        <p:txBody>
-          <a:bodyPr wrap="square" lIns="0" tIns="0" rIns="0" bIns="0" rtlCol="0" anchor="ctr"/>
-          <a:lstStyle/>
-          <a:p>
-            <a:pPr indent="0" marL="0">
-              <a:buNone/>
-            </a:pPr>
-            <a:r>
-              <a:rPr lang="en-US" sz="1000" i="1" dirty="0">
-                <a:solidFill>
-                  <a:srgbClr val="5B6B8A"/>
-                </a:solidFill>
-                <a:latin typeface="Calibri" pitchFamily="34" charset="0"/>
-                <a:ea typeface="Calibri" pitchFamily="34" charset="-122"/>
-                <a:cs typeface="Calibri" pitchFamily="34" charset="-120"/>
-              </a:rPr>
-              <a:t>stock Meshtastic firmware</a:t>
-            </a:r>
-            <a:endParaRPr lang="en-US" sz="1000" dirty="0"/>
-          </a:p>
-        </p:txBody>
-      </p:sp>
-      <p:sp>
-        <p:nvSpPr>
-          <p:cNvPr id="17" name="Shape 15"/>
-          <p:cNvSpPr/>
-          <p:nvPr/>
-        </p:nvSpPr>
-        <p:spPr>
-          <a:xfrm>
-            <a:off x="6217920" y="2697480"/>
-            <a:ext cx="0" cy="548640"/>
-          </a:xfrm>
-          <a:prstGeom prst="line">
-            <a:avLst/>
-          </a:prstGeom>
-          <a:noFill/>
-          <a:ln w="25400">
-            <a:solidFill>
-              <a:srgbClr val="E58E1A"/>
-            </a:solidFill>
-            <a:prstDash val="solid"/>
-            <a:tailEnd type="triangle"/>
-          </a:ln>
-        </p:spPr>
-      </p:sp>
-      <p:sp>
-        <p:nvSpPr>
-          <p:cNvPr id="18" name="Text 16"/>
-          <p:cNvSpPr txBox="1"/>
-          <p:nvPr/>
-        </p:nvSpPr>
-        <p:spPr>
-          <a:xfrm>
-            <a:off x="6291072" y="2843784"/>
-            <a:ext cx="1463040" cy="256032"/>
-          </a:xfrm>
-          <a:prstGeom prst="rect">
-            <a:avLst/>
-          </a:prstGeom>
-          <a:noFill/>
-          <a:ln/>
-        </p:spPr>
-        <p:txBody>
-          <a:bodyPr wrap="square" lIns="0" tIns="0" rIns="0" bIns="0" rtlCol="0" anchor="ctr"/>
-          <a:lstStyle/>
-          <a:p>
-            <a:pPr indent="0" marL="0">
-              <a:buNone/>
-            </a:pPr>
-            <a:r>
-              <a:rPr lang="en-US" sz="950" b="1" dirty="0">
-                <a:solidFill>
-                  <a:srgbClr val="E58E1A"/>
-                </a:solidFill>
-                <a:latin typeface="Calibri" pitchFamily="34" charset="0"/>
-                <a:ea typeface="Calibri" pitchFamily="34" charset="-122"/>
-                <a:cs typeface="Calibri" pitchFamily="34" charset="-120"/>
-              </a:rPr>
-              <a:t>BLE</a:t>
-            </a:r>
-            <a:endParaRPr lang="en-US" sz="950" dirty="0"/>
-          </a:p>
-        </p:txBody>
-      </p:sp>
-      <p:sp>
-        <p:nvSpPr>
-          <p:cNvPr id="19" name="Shape 17"/>
-          <p:cNvSpPr/>
-          <p:nvPr/>
-        </p:nvSpPr>
-        <p:spPr>
-          <a:xfrm>
-            <a:off x="4800600" y="3246120"/>
-            <a:ext cx="2834640" cy="960120"/>
-          </a:xfrm>
-          <a:prstGeom prst="roundRect">
-            <a:avLst>
-              <a:gd name="adj" fmla="val 6667"/>
-            </a:avLst>
-          </a:prstGeom>
-          <a:solidFill>
-            <a:srgbClr val="FFFFFF"/>
-          </a:solidFill>
-          <a:ln w="19050">
-            <a:solidFill>
-              <a:srgbClr val="6D4BDB"/>
-            </a:solidFill>
-            <a:prstDash val="solid"/>
-          </a:ln>
-        </p:spPr>
-      </p:sp>
-      <p:sp>
-        <p:nvSpPr>
-          <p:cNvPr id="20" name="Text 18"/>
-          <p:cNvSpPr txBox="1"/>
-          <p:nvPr/>
-        </p:nvSpPr>
-        <p:spPr>
-          <a:xfrm>
-            <a:off x="4892040" y="3346704"/>
-            <a:ext cx="2697480" cy="731520"/>
-          </a:xfrm>
-          <a:prstGeom prst="rect">
-            <a:avLst/>
-          </a:prstGeom>
-          <a:noFill/>
-          <a:ln/>
-        </p:spPr>
-        <p:txBody>
-          <a:bodyPr wrap="square" lIns="0" tIns="0" rIns="0" bIns="0" rtlCol="0" anchor="ctr"/>
-          <a:lstStyle/>
-          <a:p>
-            <a:pPr indent="0" marL="0">
-              <a:buNone/>
-            </a:pPr>
-            <a:r>
-              <a:rPr lang="en-US" sz="1250" b="1" dirty="0">
-                <a:solidFill>
-                  <a:srgbClr val="1E2761"/>
-                </a:solidFill>
-                <a:latin typeface="Calibri" pitchFamily="34" charset="0"/>
-                <a:ea typeface="Calibri" pitchFamily="34" charset="-122"/>
-                <a:cs typeface="Calibri" pitchFamily="34" charset="-120"/>
-              </a:rPr>
-              <a:t>Waveshare 4.2″ RLCD — display</a:t>
-            </a:r>
-            <a:endParaRPr lang="en-US" sz="1250" dirty="0"/>
-          </a:p>
-          <a:p>
-            <a:pPr indent="0" marL="0">
-              <a:buNone/>
-            </a:pPr>
-            <a:r>
-              <a:rPr lang="en-US" sz="1050" dirty="0">
-                <a:solidFill>
-                  <a:srgbClr val="5B6B8A"/>
-                </a:solidFill>
-                <a:latin typeface="Calibri" pitchFamily="34" charset="0"/>
-                <a:ea typeface="Calibri" pitchFamily="34" charset="-122"/>
-                <a:cs typeface="Calibri" pitchFamily="34" charset="-120"/>
-              </a:rPr>
-              <a:t>our only custom firmware</a:t>
-            </a:r>
-            <a:endParaRPr lang="en-US" sz="1250" dirty="0"/>
-          </a:p>
-        </p:txBody>
-      </p:sp>
-      <p:sp>
-        <p:nvSpPr>
-          <p:cNvPr id="21" name="Shape 19"/>
-          <p:cNvSpPr/>
-          <p:nvPr/>
-        </p:nvSpPr>
-        <p:spPr>
-          <a:xfrm>
-            <a:off x="3794760" y="2212848"/>
-            <a:ext cx="777240" cy="0"/>
-          </a:xfrm>
-          <a:prstGeom prst="line">
-            <a:avLst/>
-          </a:prstGeom>
-          <a:noFill/>
-          <a:ln w="31750">
-            <a:solidFill>
-              <a:srgbClr val="1E2761"/>
-            </a:solidFill>
-            <a:prstDash val="solid"/>
-            <a:headEnd type="triangle"/>
-            <a:tailEnd type="triangle"/>
-          </a:ln>
-        </p:spPr>
-      </p:sp>
-      <p:sp>
-        <p:nvSpPr>
-          <p:cNvPr id="22" name="Text 20"/>
-          <p:cNvSpPr txBox="1"/>
-          <p:nvPr/>
-        </p:nvSpPr>
-        <p:spPr>
-          <a:xfrm>
-            <a:off x="3063240" y="1847088"/>
-            <a:ext cx="2286000" cy="274320"/>
-          </a:xfrm>
-          <a:prstGeom prst="rect">
-            <a:avLst/>
-          </a:prstGeom>
-          <a:solidFill>
-            <a:srgbClr val="FFFFFF"/>
-          </a:solidFill>
-          <a:ln/>
-        </p:spPr>
-        <p:txBody>
-          <a:bodyPr wrap="square" lIns="0" tIns="0" rIns="0" bIns="0" rtlCol="0" anchor="ctr"/>
-          <a:lstStyle/>
-          <a:p>
-            <a:pPr algn="ctr" indent="0" marL="0">
-              <a:buNone/>
-            </a:pPr>
-            <a:r>
-              <a:rPr lang="en-US" sz="1000" b="1" dirty="0">
-                <a:solidFill>
-                  <a:srgbClr val="1E2761"/>
-                </a:solidFill>
-                <a:latin typeface="Calibri" pitchFamily="34" charset="0"/>
-                <a:ea typeface="Calibri" pitchFamily="34" charset="-122"/>
-                <a:cs typeface="Calibri" pitchFamily="34" charset="-120"/>
-              </a:rPr>
-              <a:t>LoRa 915 MHz · AES · mesh</a:t>
-            </a:r>
-            <a:endParaRPr lang="en-US" sz="1000" dirty="0"/>
-          </a:p>
-        </p:txBody>
-      </p:sp>
-      <p:sp>
-        <p:nvSpPr>
-          <p:cNvPr id="23" name="Text 21"/>
-          <p:cNvSpPr txBox="1"/>
-          <p:nvPr/>
-        </p:nvSpPr>
-        <p:spPr>
-          <a:xfrm>
-            <a:off x="8229600" y="1234440"/>
-            <a:ext cx="3474720" cy="365760"/>
-          </a:xfrm>
-          <a:prstGeom prst="rect">
-            <a:avLst/>
-          </a:prstGeom>
-          <a:noFill/>
-          <a:ln/>
-        </p:spPr>
-        <p:txBody>
-          <a:bodyPr wrap="square" lIns="0" tIns="0" rIns="0" bIns="0" rtlCol="0" anchor="ctr"/>
-          <a:lstStyle/>
-          <a:p>
-            <a:pPr indent="0" marL="0">
-              <a:buNone/>
-            </a:pPr>
-            <a:r>
-              <a:rPr lang="en-US" sz="1800" b="1" dirty="0">
-                <a:solidFill>
-                  <a:srgbClr val="1E2761"/>
-                </a:solidFill>
-                <a:latin typeface="Cambria" pitchFamily="34" charset="0"/>
-                <a:ea typeface="Cambria" pitchFamily="34" charset="-122"/>
-                <a:cs typeface="Cambria" pitchFamily="34" charset="-120"/>
-              </a:rPr>
-              <a:t>Why this architecture</a:t>
-            </a:r>
-            <a:endParaRPr lang="en-US" sz="1800" dirty="0"/>
-          </a:p>
-        </p:txBody>
-      </p:sp>
-      <p:sp>
-        <p:nvSpPr>
-          <p:cNvPr id="24" name="Text 22"/>
-          <p:cNvSpPr txBox="1"/>
-          <p:nvPr/>
-        </p:nvSpPr>
-        <p:spPr>
-          <a:xfrm>
-            <a:off x="8229600" y="1645920"/>
-            <a:ext cx="3520440" cy="2834640"/>
-          </a:xfrm>
-          <a:prstGeom prst="rect">
-            <a:avLst/>
-          </a:prstGeom>
-          <a:noFill/>
-          <a:ln/>
-        </p:spPr>
-        <p:txBody>
-          <a:bodyPr wrap="square" lIns="0" tIns="0" rIns="0" bIns="0" rtlCol="0" anchor="ctr"/>
-          <a:lstStyle/>
-          <a:p>
-            <a:pPr marL="342900" indent="-342900">
-              <a:spcAft>
-                <a:spcPts val="800"/>
-              </a:spcAft>
-              <a:buSzPct val="100000"/>
-              <a:buChar char="•"/>
-            </a:pPr>
-            <a:r>
-              <a:rPr lang="en-US" sz="1250" dirty="0">
-                <a:solidFill>
-                  <a:srgbClr val="222A3F"/>
-                </a:solidFill>
-                <a:latin typeface="Calibri" pitchFamily="34" charset="0"/>
-                <a:ea typeface="Calibri" pitchFamily="34" charset="-122"/>
-                <a:cs typeface="Calibri" pitchFamily="34" charset="-120"/>
-              </a:rPr>
-              <a:t>Meshtastic Client API: documented protobuf stream over BLE — the same interface its phone apps use. No firmware fork.</a:t>
-            </a:r>
-            <a:endParaRPr lang="en-US" sz="1250" dirty="0"/>
-          </a:p>
-          <a:p>
-            <a:pPr marL="342900" indent="-342900">
-              <a:spcAft>
-                <a:spcPts val="800"/>
-              </a:spcAft>
-              <a:buSzPct val="100000"/>
-              <a:buChar char="•"/>
-            </a:pPr>
-            <a:r>
-              <a:rPr lang="en-US" sz="1250" dirty="0">
-                <a:solidFill>
-                  <a:srgbClr val="222A3F"/>
-                </a:solidFill>
-                <a:latin typeface="Calibri" pitchFamily="34" charset="0"/>
-                <a:ea typeface="Calibri" pitchFamily="34" charset="-122"/>
-                <a:cs typeface="Calibri" pitchFamily="34" charset="-120"/>
-              </a:rPr>
-              <a:t>One custom-firmware surface (the display). GPS, encryption, radio timing, mesh relay all ship pre-tested.</a:t>
-            </a:r>
-            <a:endParaRPr lang="en-US" sz="1250" dirty="0"/>
-          </a:p>
-          <a:p>
-            <a:pPr marL="342900" indent="-342900">
-              <a:spcAft>
-                <a:spcPts val="800"/>
-              </a:spcAft>
-              <a:buSzPct val="100000"/>
-              <a:buChar char="•"/>
-            </a:pPr>
-            <a:r>
-              <a:rPr lang="en-US" sz="1250" dirty="0">
-                <a:solidFill>
-                  <a:srgbClr val="222A3F"/>
-                </a:solidFill>
-                <a:latin typeface="Calibri" pitchFamily="34" charset="0"/>
-                <a:ea typeface="Calibri" pitchFamily="34" charset="-122"/>
-                <a:cs typeface="Calibri" pitchFamily="34" charset="-120"/>
-              </a:rPr>
-              <a:t>Any third node (ridge relay, hiker) extends range automatically — mesh for free.</a:t>
-            </a:r>
-            <a:endParaRPr lang="en-US" sz="1250" dirty="0"/>
-          </a:p>
-          <a:p>
-            <a:pPr marL="342900" indent="-342900">
-              <a:buSzPct val="100000"/>
-              <a:buChar char="•"/>
-            </a:pPr>
-            <a:r>
-              <a:rPr lang="en-US" sz="1250" dirty="0">
-                <a:solidFill>
-                  <a:srgbClr val="222A3F"/>
-                </a:solidFill>
-                <a:latin typeface="Calibri" pitchFamily="34" charset="0"/>
-                <a:ea typeface="Calibri" pitchFamily="34" charset="-122"/>
-                <a:cs typeface="Calibri" pitchFamily="34" charset="-120"/>
-              </a:rPr>
-              <a:t>Reflective LCD: sunlight-readable on a dash where TFTs wash out; fast enough for a live arrow.</a:t>
-            </a:r>
-            <a:endParaRPr lang="en-US" sz="1250" dirty="0"/>
-          </a:p>
-        </p:txBody>
-      </p:sp>
-      <p:sp>
-        <p:nvSpPr>
-          <p:cNvPr id="25" name="Text 23"/>
-          <p:cNvSpPr txBox="1"/>
-          <p:nvPr/>
-        </p:nvSpPr>
-        <p:spPr>
-          <a:xfrm>
-            <a:off x="502920" y="4709160"/>
-            <a:ext cx="2743200" cy="320040"/>
-          </a:xfrm>
-          <a:prstGeom prst="rect">
-            <a:avLst/>
-          </a:prstGeom>
-          <a:noFill/>
-          <a:ln/>
-        </p:spPr>
-        <p:txBody>
-          <a:bodyPr wrap="square" lIns="0" tIns="0" rIns="0" bIns="0" rtlCol="0" anchor="ctr"/>
-          <a:lstStyle/>
-          <a:p>
-            <a:pPr indent="0" marL="0">
-              <a:buNone/>
-            </a:pPr>
-            <a:r>
-              <a:rPr lang="en-US" sz="1500" b="1" dirty="0">
-                <a:solidFill>
-                  <a:srgbClr val="1E2761"/>
-                </a:solidFill>
-                <a:latin typeface="Cambria" pitchFamily="34" charset="0"/>
-                <a:ea typeface="Cambria" pitchFamily="34" charset="-122"/>
-                <a:cs typeface="Cambria" pitchFamily="34" charset="-120"/>
-              </a:rPr>
-              <a:t>Protocol stack</a:t>
-            </a:r>
-            <a:endParaRPr lang="en-US" sz="1500" dirty="0"/>
-          </a:p>
-        </p:txBody>
-      </p:sp>
-      <p:sp>
-        <p:nvSpPr>
-          <p:cNvPr id="26" name="Shape 24"/>
-          <p:cNvSpPr/>
-          <p:nvPr/>
-        </p:nvSpPr>
-        <p:spPr>
-          <a:xfrm>
-            <a:off x="502920" y="5074920"/>
-            <a:ext cx="2697480" cy="914400"/>
-          </a:xfrm>
-          <a:prstGeom prst="roundRect">
-            <a:avLst>
-              <a:gd name="adj" fmla="val 7000"/>
-            </a:avLst>
-          </a:prstGeom>
-          <a:solidFill>
-            <a:srgbClr val="F2F6FC"/>
-          </a:solidFill>
-          <a:ln w="12700">
-            <a:solidFill>
-              <a:srgbClr val="1E2761"/>
-            </a:solidFill>
-            <a:prstDash val="solid"/>
-          </a:ln>
-        </p:spPr>
-      </p:sp>
-      <p:sp>
-        <p:nvSpPr>
-          <p:cNvPr id="27" name="Text 25"/>
-          <p:cNvSpPr txBox="1"/>
-          <p:nvPr/>
-        </p:nvSpPr>
-        <p:spPr>
-          <a:xfrm>
-            <a:off x="630936" y="5148072"/>
-            <a:ext cx="2468880" cy="274320"/>
-          </a:xfrm>
-          <a:prstGeom prst="rect">
-            <a:avLst/>
-          </a:prstGeom>
-          <a:noFill/>
-          <a:ln/>
-        </p:spPr>
-        <p:txBody>
-          <a:bodyPr wrap="square" lIns="0" tIns="0" rIns="0" bIns="0" rtlCol="0" anchor="ctr"/>
-          <a:lstStyle/>
-          <a:p>
-            <a:pPr indent="0" marL="0">
-              <a:buNone/>
-            </a:pPr>
-            <a:r>
-              <a:rPr lang="en-US" sz="1200" b="1" dirty="0">
-                <a:solidFill>
-                  <a:srgbClr val="E58E1A"/>
-                </a:solidFill>
-                <a:latin typeface="Calibri" pitchFamily="34" charset="0"/>
-                <a:ea typeface="Calibri" pitchFamily="34" charset="-122"/>
-                <a:cs typeface="Calibri" pitchFamily="34" charset="-120"/>
-              </a:rPr>
-              <a:t>APP</a:t>
-            </a:r>
-            <a:endParaRPr lang="en-US" sz="1200" dirty="0"/>
-          </a:p>
-        </p:txBody>
-      </p:sp>
-      <p:sp>
-        <p:nvSpPr>
-          <p:cNvPr id="28" name="Text 26"/>
-          <p:cNvSpPr txBox="1"/>
-          <p:nvPr/>
-        </p:nvSpPr>
-        <p:spPr>
-          <a:xfrm>
-            <a:off x="630936" y="5413248"/>
-            <a:ext cx="2468880" cy="502920"/>
-          </a:xfrm>
-          <a:prstGeom prst="rect">
-            <a:avLst/>
-          </a:prstGeom>
-          <a:noFill/>
-          <a:ln/>
-        </p:spPr>
-        <p:txBody>
-          <a:bodyPr wrap="square" lIns="0" tIns="0" rIns="0" bIns="0" rtlCol="0" anchor="ctr"/>
-          <a:lstStyle/>
-          <a:p>
-            <a:pPr indent="0" marL="0">
-              <a:buNone/>
-            </a:pPr>
-            <a:r>
-              <a:rPr lang="en-US" sz="1050" dirty="0">
-                <a:solidFill>
-                  <a:srgbClr val="222A3F"/>
-                </a:solidFill>
-                <a:latin typeface="Calibri" pitchFamily="34" charset="0"/>
-                <a:ea typeface="Calibri" pitchFamily="34" charset="-122"/>
-                <a:cs typeface="Calibri" pitchFamily="34" charset="-120"/>
-              </a:rPr>
-              <a:t>Position payload (protobuf, ~40 B)</a:t>
-            </a:r>
-            <a:endParaRPr lang="en-US" sz="1050" dirty="0"/>
-          </a:p>
-        </p:txBody>
-      </p:sp>
-      <p:sp>
-        <p:nvSpPr>
-          <p:cNvPr id="29" name="Shape 27"/>
-          <p:cNvSpPr/>
-          <p:nvPr/>
-        </p:nvSpPr>
-        <p:spPr>
-          <a:xfrm>
-            <a:off x="3355848" y="5074920"/>
-            <a:ext cx="2697480" cy="914400"/>
-          </a:xfrm>
-          <a:prstGeom prst="roundRect">
-            <a:avLst>
-              <a:gd name="adj" fmla="val 7000"/>
-            </a:avLst>
-          </a:prstGeom>
-          <a:solidFill>
-            <a:srgbClr val="F2F6FC"/>
-          </a:solidFill>
-          <a:ln w="12700">
-            <a:solidFill>
-              <a:srgbClr val="1E2761"/>
-            </a:solidFill>
-            <a:prstDash val="solid"/>
-          </a:ln>
-        </p:spPr>
-      </p:sp>
-      <p:sp>
-        <p:nvSpPr>
-          <p:cNvPr id="30" name="Text 28"/>
-          <p:cNvSpPr txBox="1"/>
-          <p:nvPr/>
-        </p:nvSpPr>
-        <p:spPr>
-          <a:xfrm>
-            <a:off x="3483864" y="5148072"/>
-            <a:ext cx="2468880" cy="274320"/>
-          </a:xfrm>
-          <a:prstGeom prst="rect">
-            <a:avLst/>
-          </a:prstGeom>
-          <a:noFill/>
-          <a:ln/>
-        </p:spPr>
-        <p:txBody>
-          <a:bodyPr wrap="square" lIns="0" tIns="0" rIns="0" bIns="0" rtlCol="0" anchor="ctr"/>
-          <a:lstStyle/>
-          <a:p>
-            <a:pPr indent="0" marL="0">
-              <a:buNone/>
-            </a:pPr>
-            <a:r>
-              <a:rPr lang="en-US" sz="1200" b="1" dirty="0">
-                <a:solidFill>
-                  <a:srgbClr val="E58E1A"/>
-                </a:solidFill>
-                <a:latin typeface="Calibri" pitchFamily="34" charset="0"/>
-                <a:ea typeface="Calibri" pitchFamily="34" charset="-122"/>
-                <a:cs typeface="Calibri" pitchFamily="34" charset="-120"/>
-              </a:rPr>
-              <a:t>NET</a:t>
-            </a:r>
-            <a:endParaRPr lang="en-US" sz="1200" dirty="0"/>
-          </a:p>
-        </p:txBody>
-      </p:sp>
-      <p:sp>
-        <p:nvSpPr>
-          <p:cNvPr id="31" name="Text 29"/>
-          <p:cNvSpPr txBox="1"/>
-          <p:nvPr/>
-        </p:nvSpPr>
-        <p:spPr>
-          <a:xfrm>
-            <a:off x="3483864" y="5413248"/>
-            <a:ext cx="2468880" cy="502920"/>
-          </a:xfrm>
-          <a:prstGeom prst="rect">
-            <a:avLst/>
-          </a:prstGeom>
-          <a:noFill/>
-          <a:ln/>
-        </p:spPr>
-        <p:txBody>
-          <a:bodyPr wrap="square" lIns="0" tIns="0" rIns="0" bIns="0" rtlCol="0" anchor="ctr"/>
-          <a:lstStyle/>
-          <a:p>
-            <a:pPr indent="0" marL="0">
-              <a:buNone/>
-            </a:pPr>
-            <a:r>
-              <a:rPr lang="en-US" sz="1050" dirty="0">
-                <a:solidFill>
-                  <a:srgbClr val="222A3F"/>
-                </a:solidFill>
-                <a:latin typeface="Calibri" pitchFamily="34" charset="0"/>
-                <a:ea typeface="Calibri" pitchFamily="34" charset="-122"/>
-                <a:cs typeface="Calibri" pitchFamily="34" charset="-120"/>
-              </a:rPr>
-              <a:t>Managed flooding · hop limit 3 · AES-256</a:t>
-            </a:r>
-            <a:endParaRPr lang="en-US" sz="1050" dirty="0"/>
-          </a:p>
-        </p:txBody>
-      </p:sp>
-      <p:sp>
-        <p:nvSpPr>
-          <p:cNvPr id="32" name="Shape 30"/>
-          <p:cNvSpPr/>
-          <p:nvPr/>
-        </p:nvSpPr>
-        <p:spPr>
-          <a:xfrm>
-            <a:off x="6208776" y="5074920"/>
-            <a:ext cx="2697480" cy="914400"/>
-          </a:xfrm>
-          <a:prstGeom prst="roundRect">
-            <a:avLst>
-              <a:gd name="adj" fmla="val 7000"/>
-            </a:avLst>
-          </a:prstGeom>
-          <a:solidFill>
-            <a:srgbClr val="F2F6FC"/>
-          </a:solidFill>
-          <a:ln w="12700">
-            <a:solidFill>
-              <a:srgbClr val="1E2761"/>
-            </a:solidFill>
-            <a:prstDash val="solid"/>
-          </a:ln>
-        </p:spPr>
-      </p:sp>
-      <p:sp>
-        <p:nvSpPr>
-          <p:cNvPr id="33" name="Text 31"/>
-          <p:cNvSpPr txBox="1"/>
-          <p:nvPr/>
-        </p:nvSpPr>
-        <p:spPr>
-          <a:xfrm>
-            <a:off x="6336792" y="5148072"/>
-            <a:ext cx="2468880" cy="274320"/>
-          </a:xfrm>
-          <a:prstGeom prst="rect">
-            <a:avLst/>
-          </a:prstGeom>
-          <a:noFill/>
-          <a:ln/>
-        </p:spPr>
-        <p:txBody>
-          <a:bodyPr wrap="square" lIns="0" tIns="0" rIns="0" bIns="0" rtlCol="0" anchor="ctr"/>
-          <a:lstStyle/>
-          <a:p>
-            <a:pPr indent="0" marL="0">
-              <a:buNone/>
-            </a:pPr>
-            <a:r>
-              <a:rPr lang="en-US" sz="1200" b="1" dirty="0">
-                <a:solidFill>
-                  <a:srgbClr val="E58E1A"/>
-                </a:solidFill>
-                <a:latin typeface="Calibri" pitchFamily="34" charset="0"/>
-                <a:ea typeface="Calibri" pitchFamily="34" charset="-122"/>
-                <a:cs typeface="Calibri" pitchFamily="34" charset="-120"/>
-              </a:rPr>
-              <a:t>MAC</a:t>
-            </a:r>
-            <a:endParaRPr lang="en-US" sz="1200" dirty="0"/>
-          </a:p>
-        </p:txBody>
-      </p:sp>
-      <p:sp>
-        <p:nvSpPr>
-          <p:cNvPr id="34" name="Text 32"/>
-          <p:cNvSpPr txBox="1"/>
-          <p:nvPr/>
-        </p:nvSpPr>
-        <p:spPr>
-          <a:xfrm>
-            <a:off x="6336792" y="5413248"/>
-            <a:ext cx="2468880" cy="502920"/>
-          </a:xfrm>
-          <a:prstGeom prst="rect">
-            <a:avLst/>
-          </a:prstGeom>
-          <a:noFill/>
-          <a:ln/>
-        </p:spPr>
-        <p:txBody>
-          <a:bodyPr wrap="square" lIns="0" tIns="0" rIns="0" bIns="0" rtlCol="0" anchor="ctr"/>
-          <a:lstStyle/>
-          <a:p>
-            <a:pPr indent="0" marL="0">
-              <a:buNone/>
-            </a:pPr>
-            <a:r>
-              <a:rPr lang="en-US" sz="1050" dirty="0">
-                <a:solidFill>
-                  <a:srgbClr val="222A3F"/>
-                </a:solidFill>
-                <a:latin typeface="Calibri" pitchFamily="34" charset="0"/>
-                <a:ea typeface="Calibri" pitchFamily="34" charset="-122"/>
-                <a:cs typeface="Calibri" pitchFamily="34" charset="-120"/>
-              </a:rPr>
-              <a:t>CSMA, SNR-weighted backoff</a:t>
-            </a:r>
-            <a:endParaRPr lang="en-US" sz="1050" dirty="0"/>
-          </a:p>
-        </p:txBody>
-      </p:sp>
-      <p:sp>
-        <p:nvSpPr>
-          <p:cNvPr id="35" name="Shape 33"/>
-          <p:cNvSpPr/>
-          <p:nvPr/>
-        </p:nvSpPr>
-        <p:spPr>
-          <a:xfrm>
-            <a:off x="9061704" y="5074920"/>
-            <a:ext cx="2697480" cy="914400"/>
-          </a:xfrm>
-          <a:prstGeom prst="roundRect">
-            <a:avLst>
-              <a:gd name="adj" fmla="val 7000"/>
-            </a:avLst>
-          </a:prstGeom>
-          <a:solidFill>
-            <a:srgbClr val="1E2761"/>
-          </a:solidFill>
-          <a:ln w="12700">
-            <a:solidFill>
-              <a:srgbClr val="1E2761"/>
-            </a:solidFill>
-            <a:prstDash val="solid"/>
-          </a:ln>
-        </p:spPr>
-      </p:sp>
-      <p:sp>
-        <p:nvSpPr>
-          <p:cNvPr id="36" name="Text 34"/>
-          <p:cNvSpPr txBox="1"/>
-          <p:nvPr/>
-        </p:nvSpPr>
-        <p:spPr>
-          <a:xfrm>
-            <a:off x="9189720" y="5148072"/>
-            <a:ext cx="2468880" cy="274320"/>
-          </a:xfrm>
-          <a:prstGeom prst="rect">
-            <a:avLst/>
-          </a:prstGeom>
-          <a:noFill/>
-          <a:ln/>
-        </p:spPr>
-        <p:txBody>
-          <a:bodyPr wrap="square" lIns="0" tIns="0" rIns="0" bIns="0" rtlCol="0" anchor="ctr"/>
-          <a:lstStyle/>
-          <a:p>
-            <a:pPr indent="0" marL="0">
-              <a:buNone/>
-            </a:pPr>
-            <a:r>
-              <a:rPr lang="en-US" sz="1200" b="1" dirty="0">
-                <a:solidFill>
-                  <a:srgbClr val="E58E1A"/>
-                </a:solidFill>
-                <a:latin typeface="Calibri" pitchFamily="34" charset="0"/>
-                <a:ea typeface="Calibri" pitchFamily="34" charset="-122"/>
-                <a:cs typeface="Calibri" pitchFamily="34" charset="-120"/>
-              </a:rPr>
-              <a:t>PHY</a:t>
-            </a:r>
-            <a:endParaRPr lang="en-US" sz="1200" dirty="0"/>
-          </a:p>
-        </p:txBody>
-      </p:sp>
-      <p:sp>
-        <p:nvSpPr>
-          <p:cNvPr id="37" name="Text 35"/>
-          <p:cNvSpPr txBox="1"/>
-          <p:nvPr/>
-        </p:nvSpPr>
-        <p:spPr>
-          <a:xfrm>
-            <a:off x="9189720" y="5413248"/>
-            <a:ext cx="2468880" cy="502920"/>
-          </a:xfrm>
-          <a:prstGeom prst="rect">
-            <a:avLst/>
-          </a:prstGeom>
-          <a:noFill/>
-          <a:ln/>
-        </p:spPr>
-        <p:txBody>
-          <a:bodyPr wrap="square" lIns="0" tIns="0" rIns="0" bIns="0" rtlCol="0" anchor="ctr"/>
-          <a:lstStyle/>
-          <a:p>
-            <a:pPr indent="0" marL="0">
-              <a:buNone/>
-            </a:pPr>
-            <a:r>
-              <a:rPr lang="en-US" sz="1050" dirty="0">
-                <a:solidFill>
-                  <a:srgbClr val="FFFFFF"/>
-                </a:solidFill>
-                <a:latin typeface="Calibri" pitchFamily="34" charset="0"/>
-                <a:ea typeface="Calibri" pitchFamily="34" charset="-122"/>
-                <a:cs typeface="Calibri" pitchFamily="34" charset="-120"/>
-              </a:rPr>
-              <a:t>LoRa chirp spread spectrum · 915 MHz ISM</a:t>
-            </a:r>
-            <a:endParaRPr lang="en-US" sz="1050" dirty="0"/>
-          </a:p>
-        </p:txBody>
-      </p:sp>
-    </p:spTree>
-  </p:cSld>
-  <p:clrMapOvr>
-    <a:masterClrMapping/>
-  </p:clrMapOvr>
-</p:sld>
-</file>
-
-<file path=ppt/slides/slide3.xml><?xml version="1.0" encoding="utf-8"?>
-<p:sld xmlns:a="http://schemas.openxmlformats.org/drawingml/2006/main" xmlns:r="http://schemas.openxmlformats.org/officeDocument/2006/relationships" xmlns:p="http://schemas.openxmlformats.org/presentationml/2006/main">
-  <p:cSld name="Slide 3">
-    <p:bg>
-      <p:bgPr>
-        <a:solidFill>
-          <a:srgbClr val="FFFFFF"/>
-        </a:solidFill>
-      </p:bgPr>
-    </p:bg>
-    <p:spTree>
-      <p:nvGrpSpPr>
-        <p:cNvPr id="1" name=""/>
-        <p:cNvGrpSpPr/>
-        <p:nvPr/>
-      </p:nvGrpSpPr>
-      <p:grpSpPr>
-        <a:xfrm>
-          <a:off x="0" y="0"/>
-          <a:ext cx="0" cy="0"/>
-          <a:chOff x="0" y="0"/>
-          <a:chExt cx="0" cy="0"/>
-        </a:xfrm>
-      </p:grpSpPr>
-      <p:sp>
-        <p:nvSpPr>
-          <p:cNvPr id="2" name="Text 0"/>
-          <p:cNvSpPr txBox="1"/>
-          <p:nvPr/>
-        </p:nvSpPr>
-        <p:spPr>
-          <a:xfrm>
-            <a:off x="502920" y="256032"/>
-            <a:ext cx="10058400" cy="685800"/>
-          </a:xfrm>
-          <a:prstGeom prst="rect">
-            <a:avLst/>
-          </a:prstGeom>
-          <a:noFill/>
-          <a:ln/>
-        </p:spPr>
-        <p:txBody>
-          <a:bodyPr wrap="square" lIns="0" tIns="0" rIns="0" bIns="0" rtlCol="0" anchor="ctr"/>
-          <a:lstStyle/>
-          <a:p>
-            <a:pPr indent="0" marL="0">
-              <a:buNone/>
-            </a:pPr>
-            <a:r>
-              <a:rPr lang="en-US" sz="3000" b="1" dirty="0">
-                <a:solidFill>
-                  <a:srgbClr val="1E2761"/>
-                </a:solidFill>
-                <a:latin typeface="Cambria" pitchFamily="34" charset="0"/>
-                <a:ea typeface="Cambria" pitchFamily="34" charset="-122"/>
-                <a:cs typeface="Cambria" pitchFamily="34" charset="-120"/>
-              </a:rPr>
               <a:t>Weeks 1–2 · Shared Foundations</a:t>
             </a:r>
             <a:endParaRPr lang="en-US" sz="3000" dirty="0"/>
@@ -4146,7 +2740,7 @@
       </p:sp>
       <p:graphicFrame>
         <p:nvGraphicFramePr>
-          <p:cNvPr id="4" name="Table 0"/>
+          <p:cNvPr id="3" name="Table 0"/>
           <p:cNvGraphicFramePr>
             <a:graphicFrameLocks noGrp="1"/>
           </p:cNvGraphicFramePr>
@@ -5147,6 +3741,304 @@
 </p:sld>
 </file>
 
+<file path=ppt/slides/slide3.xml><?xml version="1.0" encoding="utf-8"?>
+<p:sld xmlns:a="http://schemas.openxmlformats.org/drawingml/2006/main" xmlns:r="http://schemas.openxmlformats.org/officeDocument/2006/relationships" xmlns:p="http://schemas.openxmlformats.org/presentationml/2006/main">
+  <p:cSld name="Slide 3">
+    <p:bg>
+      <p:bgPr>
+        <a:solidFill>
+          <a:srgbClr val="FFFFFF"/>
+        </a:solidFill>
+      </p:bgPr>
+    </p:bg>
+    <p:spTree>
+      <p:nvGrpSpPr>
+        <p:cNvPr id="1" name=""/>
+        <p:cNvGrpSpPr/>
+        <p:nvPr/>
+      </p:nvGrpSpPr>
+      <p:grpSpPr>
+        <a:xfrm>
+          <a:off x="0" y="0"/>
+          <a:ext cx="0" cy="0"/>
+          <a:chOff x="0" y="0"/>
+          <a:chExt cx="0" cy="0"/>
+        </a:xfrm>
+      </p:grpSpPr>
+      <p:sp>
+        <p:nvSpPr>
+          <p:cNvPr id="2" name="Text 0"/>
+          <p:cNvSpPr txBox="1"/>
+          <p:nvPr/>
+        </p:nvSpPr>
+        <p:spPr>
+          <a:xfrm>
+            <a:off x="502920" y="256032"/>
+            <a:ext cx="10058400" cy="685800"/>
+          </a:xfrm>
+          <a:prstGeom prst="rect">
+            <a:avLst/>
+          </a:prstGeom>
+          <a:noFill/>
+          <a:ln/>
+        </p:spPr>
+        <p:txBody>
+          <a:bodyPr wrap="square" lIns="0" tIns="0" rIns="0" bIns="0" rtlCol="0" anchor="ctr"/>
+          <a:lstStyle/>
+          <a:p>
+            <a:pPr indent="0" marL="0">
+              <a:buNone/>
+            </a:pPr>
+            <a:r>
+              <a:rPr lang="en-US" sz="3000" b="1" dirty="0">
+                <a:solidFill>
+                  <a:srgbClr val="1E2761"/>
+                </a:solidFill>
+                <a:latin typeface="Cambria" pitchFamily="34" charset="0"/>
+                <a:ea typeface="Cambria" pitchFamily="34" charset="-122"/>
+                <a:cs typeface="Cambria" pitchFamily="34" charset="-120"/>
+              </a:rPr>
+              <a:t>The Complete System — One Page</a:t>
+            </a:r>
+            <a:endParaRPr lang="en-US" sz="3000" dirty="0"/>
+          </a:p>
+        </p:txBody>
+      </p:sp>
+      <p:pic>
+        <p:nvPicPr>
+          <p:cNvPr id="3" name="Image 0" descr="C:/Users/deogr/Documents/Fall Project/Off-Grid Vehicle dection project/docs/system-diagram.png">    </p:cNvPr>
+          <p:cNvPicPr>
+            <a:picLocks noChangeAspect="1"/>
+          </p:cNvPicPr>
+          <p:nvPr/>
+        </p:nvPicPr>
+        <p:blipFill>
+          <a:blip r:embed="rId1"/>
+          <a:stretch>
+            <a:fillRect/>
+          </a:stretch>
+        </p:blipFill>
+        <p:spPr>
+          <a:xfrm>
+            <a:off x="365760" y="960120"/>
+            <a:ext cx="5742432" cy="5769864"/>
+          </a:xfrm>
+          <a:prstGeom prst="rect">
+            <a:avLst/>
+          </a:prstGeom>
+        </p:spPr>
+      </p:pic>
+      <p:sp>
+        <p:nvSpPr>
+          <p:cNvPr id="4" name="Text 1"/>
+          <p:cNvSpPr txBox="1"/>
+          <p:nvPr/>
+        </p:nvSpPr>
+        <p:spPr>
+          <a:xfrm>
+            <a:off x="6492240" y="1188720"/>
+            <a:ext cx="5120640" cy="365760"/>
+          </a:xfrm>
+          <a:prstGeom prst="rect">
+            <a:avLst/>
+          </a:prstGeom>
+          <a:noFill/>
+          <a:ln/>
+        </p:spPr>
+        <p:txBody>
+          <a:bodyPr wrap="square" lIns="0" tIns="0" rIns="0" bIns="0" rtlCol="0" anchor="ctr"/>
+          <a:lstStyle/>
+          <a:p>
+            <a:pPr indent="0" marL="0">
+              <a:buNone/>
+            </a:pPr>
+            <a:r>
+              <a:rPr lang="en-US" sz="1700" b="1" dirty="0">
+                <a:solidFill>
+                  <a:srgbClr val="1E2761"/>
+                </a:solidFill>
+                <a:latin typeface="Cambria" pitchFamily="34" charset="0"/>
+                <a:ea typeface="Cambria" pitchFamily="34" charset="-122"/>
+                <a:cs typeface="Cambria" pitchFamily="34" charset="-120"/>
+              </a:rPr>
+              <a:t>How to read it</a:t>
+            </a:r>
+            <a:endParaRPr lang="en-US" sz="1700" dirty="0"/>
+          </a:p>
+        </p:txBody>
+      </p:sp>
+      <p:sp>
+        <p:nvSpPr>
+          <p:cNvPr id="5" name="Text 2"/>
+          <p:cNvSpPr txBox="1"/>
+          <p:nvPr/>
+        </p:nvSpPr>
+        <p:spPr>
+          <a:xfrm>
+            <a:off x="6492240" y="1645920"/>
+            <a:ext cx="5166360" cy="3840480"/>
+          </a:xfrm>
+          <a:prstGeom prst="rect">
+            <a:avLst/>
+          </a:prstGeom>
+          <a:noFill/>
+          <a:ln/>
+        </p:spPr>
+        <p:txBody>
+          <a:bodyPr wrap="square" lIns="0" tIns="0" rIns="0" bIns="0" rtlCol="0" anchor="ctr"/>
+          <a:lstStyle/>
+          <a:p>
+            <a:pPr marL="342900" indent="-342900">
+              <a:spcAft>
+                <a:spcPts val="1000"/>
+              </a:spcAft>
+              <a:buSzPct val="100000"/>
+              <a:buChar char="•"/>
+            </a:pPr>
+            <a:r>
+              <a:rPr lang="en-US" sz="1350" dirty="0">
+                <a:solidFill>
+                  <a:srgbClr val="222A3F"/>
+                </a:solidFill>
+                <a:latin typeface="Calibri" pitchFamily="34" charset="0"/>
+                <a:ea typeface="Calibri" pitchFamily="34" charset="-122"/>
+                <a:cs typeface="Calibri" pitchFamily="34" charset="-120"/>
+              </a:rPr>
+              <a:t>Left — one vehicle's hardware: GNSS → Heltec radio (stock Meshtastic) → roof antenna, plus the Waveshare display, all on vehicle 12 V.</a:t>
+            </a:r>
+            <a:endParaRPr lang="en-US" sz="1350" dirty="0"/>
+          </a:p>
+          <a:p>
+            <a:pPr marL="342900" indent="-342900">
+              <a:spcAft>
+                <a:spcPts val="1000"/>
+              </a:spcAft>
+              <a:buSzPct val="100000"/>
+              <a:buChar char="•"/>
+            </a:pPr>
+            <a:r>
+              <a:rPr lang="en-US" sz="1350" dirty="0">
+                <a:solidFill>
+                  <a:srgbClr val="222A3F"/>
+                </a:solidFill>
+                <a:latin typeface="Calibri" pitchFamily="34" charset="0"/>
+                <a:ea typeface="Calibri" pitchFamily="34" charset="-122"/>
+                <a:cs typeface="Calibri" pitchFamily="34" charset="-120"/>
+              </a:rPr>
+              <a:t>Right — inside the display firmware: Deo's protocol/ chain writes TrackerState; Josiah's nav/ + ui/ chain reads it. One writer, one reader.</a:t>
+            </a:r>
+            <a:endParaRPr lang="en-US" sz="1350" dirty="0"/>
+          </a:p>
+          <a:p>
+            <a:pPr marL="342900" indent="-342900">
+              <a:spcAft>
+                <a:spcPts val="1000"/>
+              </a:spcAft>
+              <a:buSzPct val="100000"/>
+              <a:buChar char="•"/>
+            </a:pPr>
+            <a:r>
+              <a:rPr lang="en-US" sz="1350" dirty="0">
+                <a:solidFill>
+                  <a:srgbClr val="222A3F"/>
+                </a:solidFill>
+                <a:latin typeface="Calibri" pitchFamily="34" charset="0"/>
+                <a:ea typeface="Calibri" pitchFamily="34" charset="-122"/>
+                <a:cs typeface="Calibri" pitchFamily="34" charset="-120"/>
+              </a:rPr>
+              <a:t>Bottom — the same system seen as telecom layers: ~40 B application payload · managed-flooding MAC with AES-256 · LoRa CSS PHY decoding 15 dB below the noise floor.</a:t>
+            </a:r>
+            <a:endParaRPr lang="en-US" sz="1350" dirty="0"/>
+          </a:p>
+          <a:p>
+            <a:pPr marL="342900" indent="-342900">
+              <a:buSzPct val="100000"/>
+              <a:buChar char="•"/>
+            </a:pPr>
+            <a:r>
+              <a:rPr lang="en-US" sz="1350" dirty="0">
+                <a:solidFill>
+                  <a:srgbClr val="222A3F"/>
+                </a:solidFill>
+                <a:latin typeface="Calibri" pitchFamily="34" charset="0"/>
+                <a:ea typeface="Calibri" pitchFamily="34" charset="-122"/>
+                <a:cs typeface="Calibri" pitchFamily="34" charset="-120"/>
+              </a:rPr>
+              <a:t>Vehicle B is an identical copy — the symmetry IS the design: no server, no master, no single point of failure.</a:t>
+            </a:r>
+            <a:endParaRPr lang="en-US" sz="1350" dirty="0"/>
+          </a:p>
+        </p:txBody>
+      </p:sp>
+      <p:sp>
+        <p:nvSpPr>
+          <p:cNvPr id="6" name="Shape 3"/>
+          <p:cNvSpPr/>
+          <p:nvPr/>
+        </p:nvSpPr>
+        <p:spPr>
+          <a:xfrm>
+            <a:off x="6492240" y="5623560"/>
+            <a:ext cx="5166360" cy="868680"/>
+          </a:xfrm>
+          <a:prstGeom prst="roundRect">
+            <a:avLst>
+              <a:gd name="adj" fmla="val 10526"/>
+            </a:avLst>
+          </a:prstGeom>
+          <a:solidFill>
+            <a:srgbClr val="1E2761"/>
+          </a:solidFill>
+          <a:ln/>
+        </p:spPr>
+      </p:sp>
+      <p:sp>
+        <p:nvSpPr>
+          <p:cNvPr id="7" name="Text 4"/>
+          <p:cNvSpPr txBox="1"/>
+          <p:nvPr/>
+        </p:nvSpPr>
+        <p:spPr>
+          <a:xfrm>
+            <a:off x="6720840" y="5715000"/>
+            <a:ext cx="4754880" cy="685800"/>
+          </a:xfrm>
+          <a:prstGeom prst="rect">
+            <a:avLst/>
+          </a:prstGeom>
+          <a:noFill/>
+          <a:ln/>
+        </p:spPr>
+        <p:txBody>
+          <a:bodyPr wrap="square" lIns="0" tIns="0" rIns="0" bIns="0" rtlCol="0" anchor="ctr"/>
+          <a:lstStyle/>
+          <a:p>
+            <a:pPr indent="0" marL="0">
+              <a:buNone/>
+            </a:pPr>
+            <a:r>
+              <a:rPr lang="en-US" sz="1250" dirty="0">
+                <a:solidFill>
+                  <a:srgbClr val="FFFFFF"/>
+                </a:solidFill>
+                <a:latin typeface="Calibri" pitchFamily="34" charset="0"/>
+                <a:ea typeface="Calibri" pitchFamily="34" charset="-122"/>
+                <a:cs typeface="Calibri" pitchFamily="34" charset="-120"/>
+              </a:rPr>
+              <a:t>Everything blue/green on the right is the team's only custom code. Everything else ships tested.</a:t>
+            </a:r>
+            <a:endParaRPr lang="en-US" sz="1250" dirty="0"/>
+          </a:p>
+        </p:txBody>
+      </p:sp>
+    </p:spTree>
+  </p:cSld>
+  <p:clrMapOvr>
+    <a:masterClrMapping/>
+  </p:clrMapOvr>
+</p:sld>
+</file>
+
 <file path=ppt/slides/slide4.xml><?xml version="1.0" encoding="utf-8"?>
 <p:sld xmlns:a="http://schemas.openxmlformats.org/drawingml/2006/main" xmlns:r="http://schemas.openxmlformats.org/officeDocument/2006/relationships" xmlns:p="http://schemas.openxmlformats.org/presentationml/2006/main">
   <p:cSld name="Slide 4">
@@ -8884,7 +7776,7 @@
                 <a:ea typeface="Calibri" pitchFamily="34" charset="-122"/>
                 <a:cs typeface="Calibri" pitchFamily="34" charset="-120"/>
               </a:rPr>
-              <a:t>ui_render task (1 Hz)</a:t>
+              <a:t>ui_render task (2 Hz)</a:t>
             </a:r>
             <a:endParaRPr lang="en-US" sz="1150" dirty="0"/>
           </a:p>
@@ -9091,7 +7983,7 @@
                 <a:ea typeface="Calibri" pitchFamily="34" charset="-122"/>
                 <a:cs typeface="Calibri" pitchFamily="34" charset="-120"/>
               </a:rPr>
-              <a:t>partner ID · units · BLE bond keys</a:t>
+              <a:t>radio BLE addr · units · partner ID (planned)</a:t>
             </a:r>
             <a:endParaRPr lang="en-US" sz="1150" dirty="0"/>
           </a:p>
@@ -9319,7 +8211,7 @@
         </p:nvSpPr>
         <p:spPr>
           <a:xfrm>
-            <a:off x="502920" y="1188720"/>
+            <a:off x="502920" y="1143000"/>
             <a:ext cx="2743200" cy="320040"/>
           </a:xfrm>
           <a:prstGeom prst="rect">
@@ -9358,12 +8250,12 @@
         </p:nvSpPr>
         <p:spPr>
           <a:xfrm>
-            <a:off x="502920" y="1600200"/>
-            <a:ext cx="1691640" cy="822960"/>
+            <a:off x="502920" y="1554480"/>
+            <a:ext cx="1645920" cy="868680"/>
           </a:xfrm>
           <a:prstGeom prst="roundRect">
             <a:avLst>
-              <a:gd name="adj" fmla="val 7778"/>
+              <a:gd name="adj" fmla="val 7368"/>
             </a:avLst>
           </a:prstGeom>
           <a:solidFill>
@@ -9385,8 +8277,8 @@
         </p:nvSpPr>
         <p:spPr>
           <a:xfrm>
-            <a:off x="594360" y="1600200"/>
-            <a:ext cx="1508760" cy="822960"/>
+            <a:off x="594360" y="1554480"/>
+            <a:ext cx="1463040" cy="868680"/>
           </a:xfrm>
           <a:prstGeom prst="rect">
             <a:avLst/>
@@ -9410,7 +8302,7 @@
                 <a:ea typeface="Calibri" pitchFamily="34" charset="-122"/>
                 <a:cs typeface="Calibri" pitchFamily="34" charset="-120"/>
               </a:rPr>
-              <a:t>GPS fix</a:t>
+              <a:t>1 · GPS fix</a:t>
             </a:r>
             <a:endParaRPr lang="en-US" sz="1150" dirty="0"/>
           </a:p>
@@ -9441,8 +8333,8 @@
         </p:nvSpPr>
         <p:spPr>
           <a:xfrm>
-            <a:off x="2194560" y="2011680"/>
-            <a:ext cx="594360" cy="0"/>
+            <a:off x="2148840" y="1984248"/>
+            <a:ext cx="502920" cy="0"/>
           </a:xfrm>
           <a:prstGeom prst="line">
             <a:avLst/>
@@ -9465,8 +8357,8 @@
         </p:nvSpPr>
         <p:spPr>
           <a:xfrm>
-            <a:off x="1874520" y="1700784"/>
-            <a:ext cx="1234440" cy="256032"/>
+            <a:off x="1828800" y="1673352"/>
+            <a:ext cx="1143000" cy="256032"/>
           </a:xfrm>
           <a:prstGeom prst="rect">
             <a:avLst/>
@@ -9504,12 +8396,12 @@
         </p:nvSpPr>
         <p:spPr>
           <a:xfrm>
-            <a:off x="2788920" y="1600200"/>
-            <a:ext cx="1920240" cy="822960"/>
+            <a:off x="2651760" y="1554480"/>
+            <a:ext cx="1828800" cy="868680"/>
           </a:xfrm>
           <a:prstGeom prst="roundRect">
             <a:avLst>
-              <a:gd name="adj" fmla="val 7778"/>
+              <a:gd name="adj" fmla="val 7368"/>
             </a:avLst>
           </a:prstGeom>
           <a:solidFill>
@@ -9531,8 +8423,8 @@
         </p:nvSpPr>
         <p:spPr>
           <a:xfrm>
-            <a:off x="2880360" y="1600200"/>
-            <a:ext cx="1737360" cy="822960"/>
+            <a:off x="2743200" y="1554480"/>
+            <a:ext cx="1645920" cy="868680"/>
           </a:xfrm>
           <a:prstGeom prst="rect">
             <a:avLst/>
@@ -9556,7 +8448,7 @@
                 <a:ea typeface="Calibri" pitchFamily="34" charset="-122"/>
                 <a:cs typeface="Calibri" pitchFamily="34" charset="-120"/>
               </a:rPr>
-              <a:t>Meshtastic B</a:t>
+              <a:t>2 · Meshtastic B</a:t>
             </a:r>
             <a:endParaRPr lang="en-US" sz="1150" dirty="0"/>
           </a:p>
@@ -9587,8 +8479,8 @@
         </p:nvSpPr>
         <p:spPr>
           <a:xfrm>
-            <a:off x="4709160" y="2011680"/>
-            <a:ext cx="1371600" cy="0"/>
+            <a:off x="4480560" y="1984248"/>
+            <a:ext cx="1417320" cy="0"/>
           </a:xfrm>
           <a:prstGeom prst="line">
             <a:avLst/>
@@ -9611,8 +8503,8 @@
         </p:nvSpPr>
         <p:spPr>
           <a:xfrm>
-            <a:off x="4389120" y="1700784"/>
-            <a:ext cx="2011680" cy="256032"/>
+            <a:off x="4160520" y="1673352"/>
+            <a:ext cx="2057400" cy="256032"/>
           </a:xfrm>
           <a:prstGeom prst="rect">
             <a:avLst/>
@@ -9650,7 +8542,7 @@
         </p:nvSpPr>
         <p:spPr>
           <a:xfrm>
-            <a:off x="4434840" y="2286000"/>
+            <a:off x="4206240" y="2240280"/>
             <a:ext cx="2011680" cy="457200"/>
           </a:xfrm>
           <a:prstGeom prst="rect">
@@ -9689,12 +8581,12 @@
         </p:nvSpPr>
         <p:spPr>
           <a:xfrm>
-            <a:off x="6080760" y="1600200"/>
-            <a:ext cx="1920240" cy="822960"/>
+            <a:off x="5897880" y="1554480"/>
+            <a:ext cx="1783080" cy="868680"/>
           </a:xfrm>
           <a:prstGeom prst="roundRect">
             <a:avLst>
-              <a:gd name="adj" fmla="val 7778"/>
+              <a:gd name="adj" fmla="val 7368"/>
             </a:avLst>
           </a:prstGeom>
           <a:solidFill>
@@ -9716,8 +8608,8 @@
         </p:nvSpPr>
         <p:spPr>
           <a:xfrm>
-            <a:off x="6172200" y="1600200"/>
-            <a:ext cx="1737360" cy="822960"/>
+            <a:off x="5989320" y="1554480"/>
+            <a:ext cx="1600200" cy="868680"/>
           </a:xfrm>
           <a:prstGeom prst="rect">
             <a:avLst/>
@@ -9741,7 +8633,7 @@
                 <a:ea typeface="Calibri" pitchFamily="34" charset="-122"/>
                 <a:cs typeface="Calibri" pitchFamily="34" charset="-120"/>
               </a:rPr>
-              <a:t>Meshtastic A</a:t>
+              <a:t>3 · Meshtastic A</a:t>
             </a:r>
             <a:endParaRPr lang="en-US" sz="1150" dirty="0"/>
           </a:p>
@@ -9750,7 +8642,7 @@
               <a:buNone/>
             </a:pPr>
             <a:r>
-              <a:rPr lang="en-US" sz="950" dirty="0">
+              <a:rPr lang="en-US" sz="900" dirty="0">
                 <a:solidFill>
                   <a:srgbClr val="5B6B8A"/>
                 </a:solidFill>
@@ -9758,7 +8650,7 @@
                 <a:ea typeface="Calibri" pitchFamily="34" charset="-122"/>
                 <a:cs typeface="Calibri" pitchFamily="34" charset="-120"/>
               </a:rPr>
-              <a:t>our radio · node DB</a:t>
+              <a:t>receives · node DB · queues FromRadio</a:t>
             </a:r>
             <a:endParaRPr lang="en-US" sz="1150" dirty="0"/>
           </a:p>
@@ -9772,7 +8664,7 @@
         </p:nvSpPr>
         <p:spPr>
           <a:xfrm>
-            <a:off x="8001000" y="2011680"/>
+            <a:off x="7680960" y="1984248"/>
             <a:ext cx="1188720" cy="0"/>
           </a:xfrm>
           <a:prstGeom prst="line">
@@ -9796,7 +8688,7 @@
         </p:nvSpPr>
         <p:spPr>
           <a:xfrm>
-            <a:off x="7680960" y="1700784"/>
+            <a:off x="7360920" y="1673352"/>
             <a:ext cx="1828800" cy="256032"/>
           </a:xfrm>
           <a:prstGeom prst="rect">
@@ -9821,7 +8713,7 @@
                 <a:ea typeface="Calibri" pitchFamily="34" charset="-122"/>
                 <a:cs typeface="Calibri" pitchFamily="34" charset="-120"/>
               </a:rPr>
-              <a:t>BLE notify → read</a:t>
+              <a:t>BLE notify → drain</a:t>
             </a:r>
             <a:endParaRPr lang="en-US" sz="950" dirty="0"/>
           </a:p>
@@ -9835,12 +8727,12 @@
         </p:nvSpPr>
         <p:spPr>
           <a:xfrm>
-            <a:off x="9189720" y="1600200"/>
-            <a:ext cx="2286000" cy="822960"/>
+            <a:off x="8869680" y="1554480"/>
+            <a:ext cx="2788920" cy="868680"/>
           </a:xfrm>
           <a:prstGeom prst="roundRect">
             <a:avLst>
-              <a:gd name="adj" fmla="val 7778"/>
+              <a:gd name="adj" fmla="val 7368"/>
             </a:avLst>
           </a:prstGeom>
           <a:solidFill>
@@ -9862,8 +8754,8 @@
         </p:nvSpPr>
         <p:spPr>
           <a:xfrm>
-            <a:off x="9281160" y="1600200"/>
-            <a:ext cx="2103120" cy="822960"/>
+            <a:off x="8961120" y="1554480"/>
+            <a:ext cx="2606040" cy="868680"/>
           </a:xfrm>
           <a:prstGeom prst="rect">
             <a:avLst/>
@@ -9887,7 +8779,7 @@
                 <a:ea typeface="Calibri" pitchFamily="34" charset="-122"/>
                 <a:cs typeface="Calibri" pitchFamily="34" charset="-120"/>
               </a:rPr>
-              <a:t>protocol/ (Deo)</a:t>
+              <a:t>4 · protocol/ (Deo)</a:t>
             </a:r>
             <a:endParaRPr lang="en-US" sz="1150" dirty="0"/>
           </a:p>
@@ -9896,7 +8788,7 @@
               <a:buNone/>
             </a:pPr>
             <a:r>
-              <a:rPr lang="en-US" sz="950" dirty="0">
+              <a:rPr lang="en-US" sz="900" dirty="0">
                 <a:solidFill>
                   <a:srgbClr val="5B6B8A"/>
                 </a:solidFill>
@@ -9904,7 +8796,7 @@
                 <a:ea typeface="Calibri" pitchFamily="34" charset="-122"/>
                 <a:cs typeface="Calibri" pitchFamily="34" charset="-120"/>
               </a:rPr>
-              <a:t>FromRadio drain · nanopb decode</a:t>
+              <a:t>read FromRadio until empty · nanopb decode → node_table</a:t>
             </a:r>
             <a:endParaRPr lang="en-US" sz="1150" dirty="0"/>
           </a:p>
@@ -9918,14 +8810,14 @@
         </p:nvSpPr>
         <p:spPr>
           <a:xfrm>
-            <a:off x="10332720" y="2423160"/>
-            <a:ext cx="0" cy="685800"/>
+            <a:off x="10259568" y="2423160"/>
+            <a:ext cx="0" cy="640080"/>
           </a:xfrm>
           <a:prstGeom prst="line">
             <a:avLst/>
           </a:prstGeom>
           <a:noFill/>
-          <a:ln w="22225">
+          <a:ln w="25400">
             <a:solidFill>
               <a:srgbClr val="1E2761"/>
             </a:solidFill>
@@ -9941,14 +8833,14 @@
         </p:nvSpPr>
         <p:spPr>
           <a:xfrm>
-            <a:off x="6035040" y="3108960"/>
-            <a:ext cx="4297680" cy="0"/>
+            <a:off x="1737360" y="3063240"/>
+            <a:ext cx="8522208" cy="0"/>
           </a:xfrm>
           <a:prstGeom prst="line">
             <a:avLst/>
           </a:prstGeom>
           <a:noFill/>
-          <a:ln w="22225">
+          <a:ln w="25400">
             <a:solidFill>
               <a:srgbClr val="1E2761"/>
             </a:solidFill>
@@ -9964,14 +8856,14 @@
         </p:nvSpPr>
         <p:spPr>
           <a:xfrm>
-            <a:off x="6035040" y="3108960"/>
+            <a:off x="1737360" y="3063240"/>
             <a:ext cx="0" cy="457200"/>
           </a:xfrm>
           <a:prstGeom prst="line">
             <a:avLst/>
           </a:prstGeom>
           <a:noFill/>
-          <a:ln w="22225">
+          <a:ln w="25400">
             <a:solidFill>
               <a:srgbClr val="1E2761"/>
             </a:solidFill>
@@ -9988,8 +8880,8 @@
         </p:nvSpPr>
         <p:spPr>
           <a:xfrm>
-            <a:off x="502920" y="3246120"/>
-            <a:ext cx="3657600" cy="320040"/>
+            <a:off x="1920240" y="3145536"/>
+            <a:ext cx="3657600" cy="292608"/>
           </a:xfrm>
           <a:prstGeom prst="rect">
             <a:avLst/>
@@ -10027,12 +8919,12 @@
         </p:nvSpPr>
         <p:spPr>
           <a:xfrm>
-            <a:off x="4892040" y="3611880"/>
-            <a:ext cx="2286000" cy="822960"/>
+            <a:off x="502920" y="3520440"/>
+            <a:ext cx="2468880" cy="868680"/>
           </a:xfrm>
           <a:prstGeom prst="roundRect">
             <a:avLst>
-              <a:gd name="adj" fmla="val 7778"/>
+              <a:gd name="adj" fmla="val 7368"/>
             </a:avLst>
           </a:prstGeom>
           <a:solidFill>
@@ -10054,8 +8946,8 @@
         </p:nvSpPr>
         <p:spPr>
           <a:xfrm>
-            <a:off x="4983480" y="3611880"/>
-            <a:ext cx="2103120" cy="822960"/>
+            <a:off x="594360" y="3520440"/>
+            <a:ext cx="2286000" cy="868680"/>
           </a:xfrm>
           <a:prstGeom prst="rect">
             <a:avLst/>
@@ -10079,7 +8971,7 @@
                 <a:ea typeface="Calibri" pitchFamily="34" charset="-122"/>
                 <a:cs typeface="Calibri" pitchFamily="34" charset="-120"/>
               </a:rPr>
-              <a:t>TrackerState</a:t>
+              <a:t>5 · TrackerState</a:t>
             </a:r>
             <a:endParaRPr lang="en-US" sz="1150" dirty="0"/>
           </a:p>
@@ -10088,7 +8980,7 @@
               <a:buNone/>
             </a:pPr>
             <a:r>
-              <a:rPr lang="en-US" sz="950" dirty="0">
+              <a:rPr lang="en-US" sz="900" dirty="0">
                 <a:solidFill>
                   <a:srgbClr val="CADCFC"/>
                 </a:solidFill>
@@ -10096,7 +8988,7 @@
                 <a:ea typeface="Calibri" pitchFamily="34" charset="-122"/>
                 <a:cs typeface="Calibri" pitchFamily="34" charset="-120"/>
               </a:rPr>
-              <a:t>self + partner + link (mutex)</a:t>
+              <a:t>self · partner · ages · clock (mutex · 1 Hz publish)</a:t>
             </a:r>
             <a:endParaRPr lang="en-US" sz="1150" dirty="0"/>
           </a:p>
@@ -10110,8 +9002,8 @@
         </p:nvSpPr>
         <p:spPr>
           <a:xfrm>
-            <a:off x="3977640" y="4023360"/>
-            <a:ext cx="868680" cy="0"/>
+            <a:off x="2971800" y="3950208"/>
+            <a:ext cx="548640" cy="0"/>
           </a:xfrm>
           <a:prstGeom prst="line">
             <a:avLst/>
@@ -10134,12 +9026,12 @@
         </p:nvSpPr>
         <p:spPr>
           <a:xfrm>
-            <a:off x="1508760" y="3611880"/>
-            <a:ext cx="2468880" cy="822960"/>
+            <a:off x="3520440" y="3520440"/>
+            <a:ext cx="2834640" cy="868680"/>
           </a:xfrm>
           <a:prstGeom prst="roundRect">
             <a:avLst>
-              <a:gd name="adj" fmla="val 7778"/>
+              <a:gd name="adj" fmla="val 7368"/>
             </a:avLst>
           </a:prstGeom>
           <a:solidFill>
@@ -10161,8 +9053,8 @@
         </p:nvSpPr>
         <p:spPr>
           <a:xfrm>
-            <a:off x="1600200" y="3611880"/>
-            <a:ext cx="2286000" cy="822960"/>
+            <a:off x="3611880" y="3520440"/>
+            <a:ext cx="2651760" cy="868680"/>
           </a:xfrm>
           <a:prstGeom prst="rect">
             <a:avLst/>
@@ -10186,7 +9078,7 @@
                 <a:ea typeface="Calibri" pitchFamily="34" charset="-122"/>
                 <a:cs typeface="Calibri" pitchFamily="34" charset="-120"/>
               </a:rPr>
-              <a:t>nav engine</a:t>
+              <a:t>6 · nav engine (Josiah)</a:t>
             </a:r>
             <a:endParaRPr lang="en-US" sz="1150" dirty="0"/>
           </a:p>
@@ -10195,7 +9087,7 @@
               <a:buNone/>
             </a:pPr>
             <a:r>
-              <a:rPr lang="en-US" sz="950" dirty="0">
+              <a:rPr lang="en-US" sz="900" dirty="0">
                 <a:solidFill>
                   <a:srgbClr val="5B6B8A"/>
                 </a:solidFill>
@@ -10203,7 +9095,7 @@
                 <a:ea typeface="Calibri" pitchFamily="34" charset="-122"/>
                 <a:cs typeface="Calibri" pitchFamily="34" charset="-120"/>
               </a:rPr>
-              <a:t>d = haversine · arrow = θ − COG</a:t>
+              <a:t>d = haversine · arrow = θ − COG · rose fallback when stopped</a:t>
             </a:r>
             <a:endParaRPr lang="en-US" sz="1150" dirty="0"/>
           </a:p>
@@ -10216,9 +9108,9 @@
           <p:nvPr/>
         </p:nvSpPr>
         <p:spPr>
-          <a:xfrm flipH="1">
-            <a:off x="1005840" y="4023360"/>
-            <a:ext cx="502920" cy="0"/>
+          <a:xfrm>
+            <a:off x="6355080" y="3950208"/>
+            <a:ext cx="548640" cy="0"/>
           </a:xfrm>
           <a:prstGeom prst="line">
             <a:avLst/>
@@ -10226,7 +9118,7 @@
           <a:noFill/>
           <a:ln w="25400">
             <a:solidFill>
-              <a:srgbClr val="6D4BDB"/>
+              <a:srgbClr val="1E2761"/>
             </a:solidFill>
             <a:prstDash val="solid"/>
             <a:tailEnd type="triangle"/>
@@ -10241,12 +9133,12 @@
         </p:nvSpPr>
         <p:spPr>
           <a:xfrm>
-            <a:off x="502920" y="4846320"/>
-            <a:ext cx="2468880" cy="822960"/>
+            <a:off x="6903720" y="3520440"/>
+            <a:ext cx="3017520" cy="868680"/>
           </a:xfrm>
           <a:prstGeom prst="roundRect">
             <a:avLst>
-              <a:gd name="adj" fmla="val 7778"/>
+              <a:gd name="adj" fmla="val 7368"/>
             </a:avLst>
           </a:prstGeom>
           <a:solidFill>
@@ -10268,8 +9160,8 @@
         </p:nvSpPr>
         <p:spPr>
           <a:xfrm>
-            <a:off x="594360" y="4846320"/>
-            <a:ext cx="2286000" cy="822960"/>
+            <a:off x="6995160" y="3520440"/>
+            <a:ext cx="2834640" cy="868680"/>
           </a:xfrm>
           <a:prstGeom prst="rect">
             <a:avLst/>
@@ -10293,7 +9185,7 @@
                 <a:ea typeface="Calibri" pitchFamily="34" charset="-122"/>
                 <a:cs typeface="Calibri" pitchFamily="34" charset="-120"/>
               </a:rPr>
-              <a:t>RLCD redraw @ 1 Hz</a:t>
+              <a:t>7 · RLCD redraw @ 2 Hz</a:t>
             </a:r>
             <a:endParaRPr lang="en-US" sz="1150" dirty="0"/>
           </a:p>
@@ -10310,7 +9202,7 @@
                 <a:ea typeface="Calibri" pitchFamily="34" charset="-122"/>
                 <a:cs typeface="Calibri" pitchFamily="34" charset="-120"/>
               </a:rPr>
-              <a:t>arrow · distance · age · link</a:t>
+              <a:t>arrow · miles · age · link · local clock</a:t>
             </a:r>
             <a:endParaRPr lang="en-US" sz="1150" dirty="0"/>
           </a:p>
@@ -10324,36 +9216,12 @@
         </p:nvSpPr>
         <p:spPr>
           <a:xfrm>
-            <a:off x="1005840" y="4434840"/>
-            <a:ext cx="0" cy="411480"/>
-          </a:xfrm>
-          <a:prstGeom prst="line">
-            <a:avLst/>
-          </a:prstGeom>
-          <a:noFill/>
-          <a:ln w="25400">
-            <a:solidFill>
-              <a:srgbClr val="6D4BDB"/>
-            </a:solidFill>
-            <a:prstDash val="solid"/>
-            <a:tailEnd type="triangle"/>
-          </a:ln>
-        </p:spPr>
-      </p:sp>
-      <p:sp>
-        <p:nvSpPr>
-          <p:cNvPr id="34" name="Shape 32"/>
-          <p:cNvSpPr/>
-          <p:nvPr/>
-        </p:nvSpPr>
-        <p:spPr>
-          <a:xfrm>
-            <a:off x="4206240" y="4846320"/>
-            <a:ext cx="7498080" cy="1417320"/>
+            <a:off x="502920" y="4800600"/>
+            <a:ext cx="11155680" cy="1463040"/>
           </a:xfrm>
           <a:prstGeom prst="roundRect">
             <a:avLst>
-              <a:gd name="adj" fmla="val 6452"/>
+              <a:gd name="adj" fmla="val 6250"/>
             </a:avLst>
           </a:prstGeom>
           <a:solidFill>
@@ -10369,14 +9237,14 @@
       </p:sp>
       <p:sp>
         <p:nvSpPr>
-          <p:cNvPr id="35" name="Text 33"/>
-          <p:cNvSpPr txBox="1"/>
-          <p:nvPr/>
-        </p:nvSpPr>
-        <p:spPr>
-          <a:xfrm>
-            <a:off x="4434840" y="4983480"/>
-            <a:ext cx="7086600" cy="1188720"/>
+          <p:cNvPr id="34" name="Text 32"/>
+          <p:cNvSpPr txBox="1"/>
+          <p:nvPr/>
+        </p:nvSpPr>
+        <p:spPr>
+          <a:xfrm>
+            <a:off x="731520" y="4956048"/>
+            <a:ext cx="10698480" cy="1188720"/>
           </a:xfrm>
           <a:prstGeom prst="rect">
             <a:avLst/>
@@ -10404,7 +9272,7 @@
                 <a:ea typeface="Calibri" pitchFamily="34" charset="-122"/>
                 <a:cs typeface="Calibri" pitchFamily="34" charset="-120"/>
               </a:rPr>
-              <a:t>Own position takes the same path minus the LoRa hop — the local radio streams its own GPS over BLE too.</a:t>
+              <a:t>Own position rides the SAME pipeline minus steps 2–3 — the local radio streams its own GPS over BLE too, so ME and PARTNER stay symmetric.</a:t>
             </a:r>
             <a:endParaRPr lang="en-US" sz="1150" dirty="0"/>
           </a:p>
@@ -10443,7 +9311,7 @@
                 <a:ea typeface="Calibri" pitchFamily="34" charset="-122"/>
                 <a:cs typeface="Calibri" pitchFamily="34" charset="-120"/>
               </a:rPr>
-              <a:t>End-to-end latency ≈ airtime (~0.5 s) — negligible next to the 30–60 s broadcast interval.</a:t>
+              <a:t>End-to-end latency ≈ airtime (~0.5 s) — negligible next to the 30–60 s broadcast cadence.</a:t>
             </a:r>
             <a:endParaRPr lang="en-US" sz="1150" dirty="0"/>
           </a:p>
@@ -10658,7 +9526,7 @@
                 <a:ea typeface="Calibri" pitchFamily="34" charset="-122"/>
                 <a:cs typeface="Calibri" pitchFamily="34" charset="-120"/>
               </a:rPr>
-              <a:t>search for the radio</a:t>
+              <a:t>direct connect by NVS addr · scan fallback</a:t>
             </a:r>
             <a:endParaRPr lang="en-US" sz="1150" dirty="0"/>
           </a:p>
@@ -10741,7 +9609,7 @@
                 <a:ea typeface="Calibri" pitchFamily="34" charset="-122"/>
                 <a:cs typeface="Calibri" pitchFamily="34" charset="-120"/>
               </a:rPr>
-              <a:t>10 s timeout</a:t>
+              <a:t>3 tries · 10 s timeout</a:t>
             </a:r>
             <a:endParaRPr lang="en-US" sz="1150" dirty="0"/>
           </a:p>
@@ -10824,7 +9692,7 @@
                 <a:ea typeface="Calibri" pitchFamily="34" charset="-122"/>
                 <a:cs typeface="Calibri" pitchFamily="34" charset="-120"/>
               </a:rPr>
-              <a:t>PIN once · keys → NVS</a:t>
+              <a:t>encrypted pairing (Just Works, NO_PIN)</a:t>
             </a:r>
             <a:endParaRPr lang="en-US" sz="1150" dirty="0"/>
           </a:p>
@@ -10907,7 +9775,7 @@
                 <a:ea typeface="Calibri" pitchFamily="34" charset="-122"/>
                 <a:cs typeface="Calibri" pitchFamily="34" charset="-120"/>
               </a:rPr>
-              <a:t>fromNum notifications</a:t>
+              <a:t>fromNum notify + want_config handshake</a:t>
             </a:r>
             <a:endParaRPr lang="en-US" sz="1150" dirty="0"/>
           </a:p>

</xml_diff>